<commit_message>
Final 18-slide deck + FLOPs efficiency analysis
</commit_message>
<xml_diff>
--- a/BTP-Reproduction/BTP_Reproduction_Deck.pptx
+++ b/BTP-Reproduction/BTP_Reproduction_Deck.pptx
@@ -22676,7 +22676,7 @@
                 <a:ea typeface="Calibri" pitchFamily="34" charset="-122"/>
                 <a:cs typeface="Calibri" pitchFamily="34" charset="-120"/>
               </a:rPr>
-              <a:t>Wall-clock latency</a:t>
+              <a:t>LLaVA-1.6 reproduction</a:t>
             </a:r>
             <a:endParaRPr lang="en-US" sz="1450" dirty="0"/>
           </a:p>
@@ -22715,7 +22715,7 @@
                 <a:ea typeface="Calibri" pitchFamily="34" charset="-122"/>
                 <a:cs typeface="Calibri" pitchFamily="34" charset="-120"/>
               </a:rPr>
-              <a:t>measure real timed speedup (FLOPs done)</a:t>
+              <a:t>once the authors release the code</a:t>
             </a:r>
             <a:endParaRPr lang="en-US" sz="1100" dirty="0"/>
           </a:p>
@@ -22844,7 +22844,7 @@
                 <a:ea typeface="Calibri" pitchFamily="34" charset="-122"/>
                 <a:cs typeface="Calibri" pitchFamily="34" charset="-120"/>
               </a:rPr>
-              <a:t>OCR-aware token pruning</a:t>
+              <a:t>Cross-model TextVQA study</a:t>
             </a:r>
             <a:endParaRPr lang="en-US" sz="1450" dirty="0"/>
           </a:p>
@@ -22883,7 +22883,7 @@
                 <a:ea typeface="Calibri" pitchFamily="34" charset="-122"/>
                 <a:cs typeface="Calibri" pitchFamily="34" charset="-120"/>
               </a:rPr>
-              <a:t>protect text tokens during pruning</a:t>
+              <a:t>test the collapse on more VLMs</a:t>
             </a:r>
             <a:endParaRPr lang="en-US" sz="1100" dirty="0"/>
           </a:p>
@@ -22891,511 +22891,7 @@
       </p:sp>
       <p:sp>
         <p:nvSpPr>
-          <p:cNvPr id="21" name="Shape 19"/>
-          <p:cNvSpPr/>
-          <p:nvPr/>
-        </p:nvSpPr>
-        <p:spPr>
-          <a:xfrm>
-            <a:off x="6263640" y="2761488"/>
-            <a:ext cx="5394960" cy="1143000"/>
-          </a:xfrm>
-          <a:prstGeom prst="roundRect">
-            <a:avLst>
-              <a:gd name="adj" fmla="val 6400"/>
-            </a:avLst>
-          </a:prstGeom>
-          <a:solidFill>
-            <a:srgbClr val="FFFFFF"/>
-          </a:solidFill>
-          <a:ln w="12700">
-            <a:solidFill>
-              <a:srgbClr val="E3EAF2"/>
-            </a:solidFill>
-            <a:prstDash val="solid"/>
-          </a:ln>
-          <a:effectLst>
-            <a:outerShdw sx="100000" sy="100000" kx="0" ky="0" algn="bl" rotWithShape="0" blurRad="88900" dist="38100" dir="8100000">
-              <a:srgbClr val="000000">
-                <a:alpha val="18000"/>
-              </a:srgbClr>
-            </a:outerShdw>
-          </a:effectLst>
-        </p:spPr>
-      </p:sp>
-      <p:sp>
-        <p:nvSpPr>
-          <p:cNvPr id="22" name="Shape 20"/>
-          <p:cNvSpPr/>
-          <p:nvPr/>
-        </p:nvSpPr>
-        <p:spPr>
-          <a:xfrm>
-            <a:off x="6492240" y="3127248"/>
-            <a:ext cx="411480" cy="411480"/>
-          </a:xfrm>
-          <a:prstGeom prst="ellipse">
-            <a:avLst/>
-          </a:prstGeom>
-          <a:solidFill>
-            <a:srgbClr val="1C7293"/>
-          </a:solidFill>
-          <a:ln/>
-        </p:spPr>
-      </p:sp>
-      <p:sp>
-        <p:nvSpPr>
-          <p:cNvPr id="23" name="Text 21"/>
-          <p:cNvSpPr/>
-          <p:nvPr/>
-        </p:nvSpPr>
-        <p:spPr>
-          <a:xfrm>
-            <a:off x="6492240" y="3127248"/>
-            <a:ext cx="411480" cy="411480"/>
-          </a:xfrm>
-          <a:prstGeom prst="rect">
-            <a:avLst/>
-          </a:prstGeom>
-          <a:noFill/>
-          <a:ln/>
-        </p:spPr>
-        <p:txBody>
-          <a:bodyPr wrap="square" rtlCol="0" anchor="ctr"/>
-          <a:lstStyle/>
-          <a:p>
-            <a:pPr algn="ctr" indent="0" marL="0">
-              <a:buNone/>
-            </a:pPr>
-            <a:r>
-              <a:rPr lang="en-US" sz="1400" b="1" dirty="0">
-                <a:solidFill>
-                  <a:srgbClr val="FFFFFF"/>
-                </a:solidFill>
-              </a:rPr>
-              <a:t>→</a:t>
-            </a:r>
-            <a:endParaRPr lang="en-US" sz="1400" dirty="0"/>
-          </a:p>
-        </p:txBody>
-      </p:sp>
-      <p:sp>
-        <p:nvSpPr>
-          <p:cNvPr id="24" name="Text 22"/>
-          <p:cNvSpPr/>
-          <p:nvPr/>
-        </p:nvSpPr>
-        <p:spPr>
-          <a:xfrm>
-            <a:off x="7086600" y="2944368"/>
-            <a:ext cx="4389120" cy="457200"/>
-          </a:xfrm>
-          <a:prstGeom prst="rect">
-            <a:avLst/>
-          </a:prstGeom>
-          <a:noFill/>
-          <a:ln/>
-        </p:spPr>
-        <p:txBody>
-          <a:bodyPr wrap="square" rtlCol="0" anchor="ctr"/>
-          <a:lstStyle/>
-          <a:p>
-            <a:pPr indent="0" marL="0">
-              <a:buNone/>
-            </a:pPr>
-            <a:r>
-              <a:rPr lang="en-US" sz="1450" b="1" dirty="0">
-                <a:solidFill>
-                  <a:srgbClr val="16222E"/>
-                </a:solidFill>
-                <a:latin typeface="Calibri" pitchFamily="34" charset="0"/>
-                <a:ea typeface="Calibri" pitchFamily="34" charset="-122"/>
-                <a:cs typeface="Calibri" pitchFamily="34" charset="-120"/>
-              </a:rPr>
-              <a:t>Dynamic pruning strategies</a:t>
-            </a:r>
-            <a:endParaRPr lang="en-US" sz="1450" dirty="0"/>
-          </a:p>
-        </p:txBody>
-      </p:sp>
-      <p:sp>
-        <p:nvSpPr>
-          <p:cNvPr id="25" name="Text 23"/>
-          <p:cNvSpPr/>
-          <p:nvPr/>
-        </p:nvSpPr>
-        <p:spPr>
-          <a:xfrm>
-            <a:off x="7086600" y="3383280"/>
-            <a:ext cx="4389120" cy="411480"/>
-          </a:xfrm>
-          <a:prstGeom prst="rect">
-            <a:avLst/>
-          </a:prstGeom>
-          <a:noFill/>
-          <a:ln/>
-        </p:spPr>
-        <p:txBody>
-          <a:bodyPr wrap="square" rtlCol="0" anchor="ctr"/>
-          <a:lstStyle/>
-          <a:p>
-            <a:pPr indent="0" marL="0">
-              <a:buNone/>
-            </a:pPr>
-            <a:r>
-              <a:rPr lang="en-US" sz="1100" dirty="0">
-                <a:solidFill>
-                  <a:srgbClr val="5A6B7B"/>
-                </a:solidFill>
-                <a:latin typeface="Calibri" pitchFamily="34" charset="0"/>
-                <a:ea typeface="Calibri" pitchFamily="34" charset="-122"/>
-                <a:cs typeface="Calibri" pitchFamily="34" charset="-120"/>
-              </a:rPr>
-              <a:t>adapt pruning strength to the task</a:t>
-            </a:r>
-            <a:endParaRPr lang="en-US" sz="1100" dirty="0"/>
-          </a:p>
-        </p:txBody>
-      </p:sp>
-      <p:sp>
-        <p:nvSpPr>
-          <p:cNvPr id="26" name="Shape 24"/>
-          <p:cNvSpPr/>
-          <p:nvPr/>
-        </p:nvSpPr>
-        <p:spPr>
-          <a:xfrm>
-            <a:off x="594360" y="4105656"/>
-            <a:ext cx="5394960" cy="1143000"/>
-          </a:xfrm>
-          <a:prstGeom prst="roundRect">
-            <a:avLst>
-              <a:gd name="adj" fmla="val 6400"/>
-            </a:avLst>
-          </a:prstGeom>
-          <a:solidFill>
-            <a:srgbClr val="FFFFFF"/>
-          </a:solidFill>
-          <a:ln w="12700">
-            <a:solidFill>
-              <a:srgbClr val="E3EAF2"/>
-            </a:solidFill>
-            <a:prstDash val="solid"/>
-          </a:ln>
-          <a:effectLst>
-            <a:outerShdw sx="100000" sy="100000" kx="0" ky="0" algn="bl" rotWithShape="0" blurRad="88900" dist="38100" dir="8100000">
-              <a:srgbClr val="000000">
-                <a:alpha val="18000"/>
-              </a:srgbClr>
-            </a:outerShdw>
-          </a:effectLst>
-        </p:spPr>
-      </p:sp>
-      <p:sp>
-        <p:nvSpPr>
-          <p:cNvPr id="27" name="Shape 25"/>
-          <p:cNvSpPr/>
-          <p:nvPr/>
-        </p:nvSpPr>
-        <p:spPr>
-          <a:xfrm>
-            <a:off x="822960" y="4471416"/>
-            <a:ext cx="411480" cy="411480"/>
-          </a:xfrm>
-          <a:prstGeom prst="ellipse">
-            <a:avLst/>
-          </a:prstGeom>
-          <a:solidFill>
-            <a:srgbClr val="1C7293"/>
-          </a:solidFill>
-          <a:ln/>
-        </p:spPr>
-      </p:sp>
-      <p:sp>
-        <p:nvSpPr>
-          <p:cNvPr id="28" name="Text 26"/>
-          <p:cNvSpPr/>
-          <p:nvPr/>
-        </p:nvSpPr>
-        <p:spPr>
-          <a:xfrm>
-            <a:off x="822960" y="4471416"/>
-            <a:ext cx="411480" cy="411480"/>
-          </a:xfrm>
-          <a:prstGeom prst="rect">
-            <a:avLst/>
-          </a:prstGeom>
-          <a:noFill/>
-          <a:ln/>
-        </p:spPr>
-        <p:txBody>
-          <a:bodyPr wrap="square" rtlCol="0" anchor="ctr"/>
-          <a:lstStyle/>
-          <a:p>
-            <a:pPr algn="ctr" indent="0" marL="0">
-              <a:buNone/>
-            </a:pPr>
-            <a:r>
-              <a:rPr lang="en-US" sz="1400" b="1" dirty="0">
-                <a:solidFill>
-                  <a:srgbClr val="FFFFFF"/>
-                </a:solidFill>
-              </a:rPr>
-              <a:t>→</a:t>
-            </a:r>
-            <a:endParaRPr lang="en-US" sz="1400" dirty="0"/>
-          </a:p>
-        </p:txBody>
-      </p:sp>
-      <p:sp>
-        <p:nvSpPr>
-          <p:cNvPr id="29" name="Text 27"/>
-          <p:cNvSpPr/>
-          <p:nvPr/>
-        </p:nvSpPr>
-        <p:spPr>
-          <a:xfrm>
-            <a:off x="1417320" y="4288536"/>
-            <a:ext cx="4389120" cy="457200"/>
-          </a:xfrm>
-          <a:prstGeom prst="rect">
-            <a:avLst/>
-          </a:prstGeom>
-          <a:noFill/>
-          <a:ln/>
-        </p:spPr>
-        <p:txBody>
-          <a:bodyPr wrap="square" rtlCol="0" anchor="ctr"/>
-          <a:lstStyle/>
-          <a:p>
-            <a:pPr indent="0" marL="0">
-              <a:buNone/>
-            </a:pPr>
-            <a:r>
-              <a:rPr lang="en-US" sz="1450" b="1" dirty="0">
-                <a:solidFill>
-                  <a:srgbClr val="16222E"/>
-                </a:solidFill>
-                <a:latin typeface="Calibri" pitchFamily="34" charset="0"/>
-                <a:ea typeface="Calibri" pitchFamily="34" charset="-122"/>
-                <a:cs typeface="Calibri" pitchFamily="34" charset="-120"/>
-              </a:rPr>
-              <a:t>LLaVA-1.6 reproduction</a:t>
-            </a:r>
-            <a:endParaRPr lang="en-US" sz="1450" dirty="0"/>
-          </a:p>
-        </p:txBody>
-      </p:sp>
-      <p:sp>
-        <p:nvSpPr>
-          <p:cNvPr id="30" name="Text 28"/>
-          <p:cNvSpPr/>
-          <p:nvPr/>
-        </p:nvSpPr>
-        <p:spPr>
-          <a:xfrm>
-            <a:off x="1417320" y="4727448"/>
-            <a:ext cx="4389120" cy="411480"/>
-          </a:xfrm>
-          <a:prstGeom prst="rect">
-            <a:avLst/>
-          </a:prstGeom>
-          <a:noFill/>
-          <a:ln/>
-        </p:spPr>
-        <p:txBody>
-          <a:bodyPr wrap="square" rtlCol="0" anchor="ctr"/>
-          <a:lstStyle/>
-          <a:p>
-            <a:pPr indent="0" marL="0">
-              <a:buNone/>
-            </a:pPr>
-            <a:r>
-              <a:rPr lang="en-US" sz="1100" dirty="0">
-                <a:solidFill>
-                  <a:srgbClr val="5A6B7B"/>
-                </a:solidFill>
-                <a:latin typeface="Calibri" pitchFamily="34" charset="0"/>
-                <a:ea typeface="Calibri" pitchFamily="34" charset="-122"/>
-                <a:cs typeface="Calibri" pitchFamily="34" charset="-120"/>
-              </a:rPr>
-              <a:t>once the authors release the code</a:t>
-            </a:r>
-            <a:endParaRPr lang="en-US" sz="1100" dirty="0"/>
-          </a:p>
-        </p:txBody>
-      </p:sp>
-      <p:sp>
-        <p:nvSpPr>
-          <p:cNvPr id="31" name="Shape 29"/>
-          <p:cNvSpPr/>
-          <p:nvPr/>
-        </p:nvSpPr>
-        <p:spPr>
-          <a:xfrm>
-            <a:off x="6263640" y="4105656"/>
-            <a:ext cx="5394960" cy="1143000"/>
-          </a:xfrm>
-          <a:prstGeom prst="roundRect">
-            <a:avLst>
-              <a:gd name="adj" fmla="val 6400"/>
-            </a:avLst>
-          </a:prstGeom>
-          <a:solidFill>
-            <a:srgbClr val="FFFFFF"/>
-          </a:solidFill>
-          <a:ln w="12700">
-            <a:solidFill>
-              <a:srgbClr val="E3EAF2"/>
-            </a:solidFill>
-            <a:prstDash val="solid"/>
-          </a:ln>
-          <a:effectLst>
-            <a:outerShdw sx="100000" sy="100000" kx="0" ky="0" algn="bl" rotWithShape="0" blurRad="88900" dist="38100" dir="8100000">
-              <a:srgbClr val="000000">
-                <a:alpha val="18000"/>
-              </a:srgbClr>
-            </a:outerShdw>
-          </a:effectLst>
-        </p:spPr>
-      </p:sp>
-      <p:sp>
-        <p:nvSpPr>
-          <p:cNvPr id="32" name="Shape 30"/>
-          <p:cNvSpPr/>
-          <p:nvPr/>
-        </p:nvSpPr>
-        <p:spPr>
-          <a:xfrm>
-            <a:off x="6492240" y="4471416"/>
-            <a:ext cx="411480" cy="411480"/>
-          </a:xfrm>
-          <a:prstGeom prst="ellipse">
-            <a:avLst/>
-          </a:prstGeom>
-          <a:solidFill>
-            <a:srgbClr val="1C7293"/>
-          </a:solidFill>
-          <a:ln/>
-        </p:spPr>
-      </p:sp>
-      <p:sp>
-        <p:nvSpPr>
-          <p:cNvPr id="33" name="Text 31"/>
-          <p:cNvSpPr/>
-          <p:nvPr/>
-        </p:nvSpPr>
-        <p:spPr>
-          <a:xfrm>
-            <a:off x="6492240" y="4471416"/>
-            <a:ext cx="411480" cy="411480"/>
-          </a:xfrm>
-          <a:prstGeom prst="rect">
-            <a:avLst/>
-          </a:prstGeom>
-          <a:noFill/>
-          <a:ln/>
-        </p:spPr>
-        <p:txBody>
-          <a:bodyPr wrap="square" rtlCol="0" anchor="ctr"/>
-          <a:lstStyle/>
-          <a:p>
-            <a:pPr algn="ctr" indent="0" marL="0">
-              <a:buNone/>
-            </a:pPr>
-            <a:r>
-              <a:rPr lang="en-US" sz="1400" b="1" dirty="0">
-                <a:solidFill>
-                  <a:srgbClr val="FFFFFF"/>
-                </a:solidFill>
-              </a:rPr>
-              <a:t>→</a:t>
-            </a:r>
-            <a:endParaRPr lang="en-US" sz="1400" dirty="0"/>
-          </a:p>
-        </p:txBody>
-      </p:sp>
-      <p:sp>
-        <p:nvSpPr>
-          <p:cNvPr id="34" name="Text 32"/>
-          <p:cNvSpPr/>
-          <p:nvPr/>
-        </p:nvSpPr>
-        <p:spPr>
-          <a:xfrm>
-            <a:off x="7086600" y="4288536"/>
-            <a:ext cx="4389120" cy="457200"/>
-          </a:xfrm>
-          <a:prstGeom prst="rect">
-            <a:avLst/>
-          </a:prstGeom>
-          <a:noFill/>
-          <a:ln/>
-        </p:spPr>
-        <p:txBody>
-          <a:bodyPr wrap="square" rtlCol="0" anchor="ctr"/>
-          <a:lstStyle/>
-          <a:p>
-            <a:pPr indent="0" marL="0">
-              <a:buNone/>
-            </a:pPr>
-            <a:r>
-              <a:rPr lang="en-US" sz="1450" b="1" dirty="0">
-                <a:solidFill>
-                  <a:srgbClr val="16222E"/>
-                </a:solidFill>
-                <a:latin typeface="Calibri" pitchFamily="34" charset="0"/>
-                <a:ea typeface="Calibri" pitchFamily="34" charset="-122"/>
-                <a:cs typeface="Calibri" pitchFamily="34" charset="-120"/>
-              </a:rPr>
-              <a:t>Cross-model TextVQA study</a:t>
-            </a:r>
-            <a:endParaRPr lang="en-US" sz="1450" dirty="0"/>
-          </a:p>
-        </p:txBody>
-      </p:sp>
-      <p:sp>
-        <p:nvSpPr>
-          <p:cNvPr id="35" name="Text 33"/>
-          <p:cNvSpPr/>
-          <p:nvPr/>
-        </p:nvSpPr>
-        <p:spPr>
-          <a:xfrm>
-            <a:off x="7086600" y="4727448"/>
-            <a:ext cx="4389120" cy="411480"/>
-          </a:xfrm>
-          <a:prstGeom prst="rect">
-            <a:avLst/>
-          </a:prstGeom>
-          <a:noFill/>
-          <a:ln/>
-        </p:spPr>
-        <p:txBody>
-          <a:bodyPr wrap="square" rtlCol="0" anchor="ctr"/>
-          <a:lstStyle/>
-          <a:p>
-            <a:pPr indent="0" marL="0">
-              <a:buNone/>
-            </a:pPr>
-            <a:r>
-              <a:rPr lang="en-US" sz="1100" dirty="0">
-                <a:solidFill>
-                  <a:srgbClr val="5A6B7B"/>
-                </a:solidFill>
-                <a:latin typeface="Calibri" pitchFamily="34" charset="0"/>
-                <a:ea typeface="Calibri" pitchFamily="34" charset="-122"/>
-                <a:cs typeface="Calibri" pitchFamily="34" charset="-120"/>
-              </a:rPr>
-              <a:t>test the collapse on more VLMs</a:t>
-            </a:r>
-            <a:endParaRPr lang="en-US" sz="1100" dirty="0"/>
-          </a:p>
-        </p:txBody>
-      </p:sp>
-      <p:sp>
-        <p:nvSpPr>
-          <p:cNvPr id="36" name="Text 34"/>
+          <p:cNvPr id="21" name="Text 19"/>
           <p:cNvSpPr/>
           <p:nvPr/>
         </p:nvSpPr>
@@ -23434,7 +22930,7 @@
       </p:sp>
       <p:sp>
         <p:nvSpPr>
-          <p:cNvPr id="37" name="Text 35"/>
+          <p:cNvPr id="22" name="Text 20"/>
           <p:cNvSpPr/>
           <p:nvPr/>
         </p:nvSpPr>

</xml_diff>